<commit_message>
Deck v8 final pass: one way of deciding, used three times (Fable-led, Opus-executed)
- Fable reassessment revisions 1-7 and all ten final-pass items applied, with three
  adaptations (slide 13 title keeps the brief's words; no T-numbers on slide 2;
  one-line titles)
- Talk track v8: new opening and close, 3,300 words (~25.4 min), checkpoints met
- Gates: OOXML valid, strict check clean, render inspected, scan 52/1, preservation
  v7->v8 0 missing; TEST_08

Co-Authored-By: Claude Opus 5.5 <noreply@anthropic.com>
Claude-Session: https://claude.ai/code/session_016cGM8N4AP69rY41a4ajBjX
</commit_message>
<xml_diff>
--- a/deck/CFO_CoS_deck_v8.pptx
+++ b/deck/CFO_CoS_deck_v8.pptx
@@ -1063,7 +1063,7 @@
           <a:lstStyle/>
           <a:p>
             <a:r>
-              <a:t>Gate 0 is the charter; four decision gates follow: can we, what may we offer, who may bind Nu, do we commit. The CFO decides each one.</a:t>
+              <a:t>Gate 0 is the charter. Four decision gates: can we, what may we offer, who may bind Nu, do we commit. The CFO decides each on my pack; nothing is signed between them.</a:t>
             </a:r>
           </a:p>
         </p:txBody>
@@ -1133,7 +1133,7 @@
           <a:lstStyle/>
           <a:p>
             <a:r>
-              <a:t>Experts own the judgment, I own the process, the CFO owns the residual risk. Licensed executives sign; I hold no power of attorney.</a:t>
+              <a:t>Experts own the judgment, I own the process, the CFO owns the residual risk. Licensed executives sign; I hold no power of attorney. Disagreements get 48 hours, then both options go to the CFO with mine.</a:t>
             </a:r>
           </a:p>
         </p:txBody>
@@ -1273,7 +1273,7 @@
           <a:lstStyle/>
           <a:p>
             <a:r>
-              <a:t>The same split in all three problems: I own the process and the recommendation, experts own the judgment, the accountable executive owns the decision.</a:t>
+              <a:t>The same split in all three problems: I own the model, the memo and the log; experts own their judgment; the accountable executive owns the decision and the signature.</a:t>
             </a:r>
           </a:p>
         </p:txBody>
@@ -1343,7 +1343,7 @@
           <a:lstStyle/>
           <a:p>
             <a:r>
-              <a:t>Three dates, three stop rules, the ask.</a:t>
+              <a:t>Three dates, three stop rules, the ask: one way of deciding, used three times, reported on in 90 days.</a:t>
             </a:r>
           </a:p>
         </p:txBody>
@@ -1693,7 +1693,7 @@
           <a:lstStyle/>
           <a:p>
             <a:r>
-              <a:t>Three problems, one way of deciding. Three decisions, each with a number; the reserve is stated up front, with its conditions.</a:t>
+              <a:t>One way of deciding, used three times. Three decisions, each with a number. The reserve is stated up front, with its conditions.</a:t>
             </a:r>
           </a:p>
         </p:txBody>
@@ -2533,7 +2533,7 @@
           <a:lstStyle/>
           <a:p>
             <a:r>
-              <a:t>Equity by entity first, as options with one test; on opex the CEO chooses between three options, and I recommend 70/30.</a:t>
+              <a:t>Equity by entity first. On opex, both positions go in the memo as options; I recommend 70/30; the CEO decides and the dissent is recorded.</a:t>
             </a:r>
           </a:p>
         </p:txBody>
@@ -7865,7 +7865,7 @@
                 </a:solidFill>
                 <a:latin typeface="Arial"/>
               </a:rPr>
-              <a:t>Experts own the judgment, I own the process, the CFO owns the residual risk</a:t>
+              <a:t>Experts own the judgment, I own the process, the CFO owns residual risk</a:t>
             </a:r>
           </a:p>
         </p:txBody>
@@ -8546,7 +8546,7 @@
                 </a:solidFill>
                 <a:latin typeface="Arial"/>
               </a:rPr>
-              <a:t>A named deputy, the decision log, and gate packs the CFO can read without me.</a:t>
+              <a:t>A named deputy, the decision log, and gate packs the CFO can decide on without me.</a:t>
             </a:r>
           </a:p>
         </p:txBody>
@@ -8712,7 +8712,7 @@
                 </a:solidFill>
                 <a:latin typeface="Arial"/>
               </a:rPr>
-              <a:t>How I balance strategic influence with hands-on rigor</a:t>
+              <a:t>Influence with hands-on rigor: a few clear rules, published early</a:t>
             </a:r>
           </a:p>
         </p:txBody>
@@ -9255,7 +9255,7 @@
                 </a:solidFill>
                 <a:latin typeface="Arial"/>
               </a:rPr>
-              <a:t>Fair process: Kim and Mauborgne (HBR). Examples from my own record follow in the talk.</a:t>
+              <a:t>Fair process: Kim and Mauborgne (HBR).</a:t>
             </a:r>
           </a:p>
         </p:txBody>
@@ -10014,7 +10014,7 @@
                 </a:solidFill>
                 <a:latin typeface="Arial"/>
               </a:rPr>
-              <a:t>Next 90 days: Board by 17 Nov, first release on 1 January, and the ask</a:t>
+              <a:t>Next 90 days: the Board on 17 Nov, the first release on 1 Jan, and the ask</a:t>
             </a:r>
           </a:p>
         </p:txBody>
@@ -10551,7 +10551,7 @@
                 </a:solidFill>
                 <a:latin typeface="Arial"/>
               </a:rPr>
-              <a:t>a unit below plan on two of four indicators has its second-release share held. Efficiency ratio above the FY26 guide at Q1 close: the second release is held for every unit. Credit cost or NPL 90+ above plan: the reserve stays shut, and Risk can block it.</a:t>
+              <a:t>a unit below plan on two of four indicators has its second-release share held. Efficiency ratio above the guide in force at Q1 close: the second release is held for every unit. Credit cost or NPL 90+ above plan: the reserve stays shut, and Risk can block it.</a:t>
             </a:r>
           </a:p>
         </p:txBody>
@@ -14741,7 +14741,7 @@
                 </a:solidFill>
                 <a:latin typeface="Arial"/>
               </a:rPr>
-              <a:t>One capital ranking</a:t>
+              <a:t>One test, one decision owner</a:t>
             </a:r>
           </a:p>
           <a:p>
@@ -14757,7 +14757,7 @@
                 </a:solidFill>
                 <a:latin typeface="Arial"/>
               </a:rPr>
-              <a:t>Both executives' positions go through the same test. The plan locks 16 days before the Board; the book ships 7 days before.</a:t>
+              <a:t>Both executives' positions go into the memo; the CEO decides at the lock; the dissent is recorded. The book ships 7 days before the Board.</a:t>
             </a:r>
           </a:p>
         </p:txBody>
@@ -14858,7 +14858,7 @@
                 </a:solidFill>
                 <a:latin typeface="Arial"/>
               </a:rPr>
-              <a:t>Four gates in 120 days</a:t>
+              <a:t>Four decision gates in 120 days</a:t>
             </a:r>
           </a:p>
           <a:p>
@@ -14874,7 +14874,7 @@
                 </a:solidFill>
                 <a:latin typeface="Arial"/>
               </a:rPr>
-              <a:t>Tax, grant terms, officers and lease, each with an owner, an exit test and a walk-away. Licensed executives sign; I run the pod.</a:t>
+              <a:t>Can we, what may we offer, who may bind Nu, do we commit: each the CFO's call on a pack I assemble. Licensed executives sign.</a:t>
             </a:r>
           </a:p>
         </p:txBody>
@@ -14991,7 +14991,7 @@
                 </a:solidFill>
                 <a:latin typeface="Arial"/>
               </a:rPr>
-              <a:t>I work in the numbers with the GMs. The CFO gets the trade-offs and makes the call.</a:t>
+              <a:t>I work in the numbers with the GMs. Experts own their judgment, I own the process, the CFO owns the decision and its risk.</a:t>
             </a:r>
           </a:p>
         </p:txBody>
@@ -19797,7 +19797,7 @@
                           </a:solidFill>
                           <a:latin typeface="Arial"/>
                         </a:rPr>
-                        <a:t>Up to $15.0M from H1 profit above plan, inside the ~20% FY26 guide</a:t>
+                        <a:t>Up to $15.0M from H1 profit above plan, inside the guide in force</a:t>
                       </a:r>
                     </a:p>
                   </a:txBody>
@@ -19865,7 +19865,7 @@
                           </a:solidFill>
                           <a:latin typeface="Arial"/>
                         </a:rPr>
-                        <a:t>Efficiency ratio above the FY26 guide at Q1 close: the second release is held for every unit</a:t>
+                        <a:t>Efficiency ratio above the guide in force at Q1 close: the second release is held for every unit</a:t>
                       </a:r>
                     </a:p>
                   </a:txBody>
@@ -22914,8 +22914,8 @@
         </p:nvSpPr>
         <p:spPr>
           <a:xfrm>
-            <a:off x="612648" y="6144768"/>
-            <a:ext cx="10515600" cy="548640"/>
+            <a:off x="612648" y="6126480"/>
+            <a:ext cx="10515600" cy="594360"/>
           </a:xfrm>
           <a:prstGeom prst="rect">
             <a:avLst/>
@@ -22936,7 +22936,7 @@
                 </a:solidFill>
                 <a:latin typeface="Arial"/>
               </a:rPr>
-              <a:t>Scores and weights are my judgment (A9); option 3 stays first if any single weight moves 10 points (backup C). Sources: Nu Q2'26 release and 6-K (opex $806.2M; net revenue ~$4.1B), Q2'26 call, Form 20-F. Calculations: revenue ~$23.5B annualized managerial; opex ~$3.2B annualized; efficiency ratio on Nu's denominator (NII plus fees).</a:t>
+              <a:t>Scores and weights are my judgment (A9); option 3 stays first if any single weight moves 10 points (backup C). Sources: Nu Q2'26 release and 6-K (opex $806.2M; net revenue ~$4.1B a quarter), Q2'26 call, Form 20-F. Calculations: the 15 bps is on managerial revenue, ~$23.5B annualized; the 1.1% is on opex, ~$3.2B annualized; the efficiency-ratio points are on Nu's denominator (NII plus fees).</a:t>
             </a:r>
           </a:p>
         </p:txBody>
@@ -24183,7 +24183,7 @@
                 </a:solidFill>
                 <a:latin typeface="Arial"/>
               </a:rPr>
-              <a:t>every case states the headcount and engineering capacity it needs, and Engineering confirms it at the lock, so a release never funds work the platform cannot staff. Partners recommend, GMs give input, I assemble the pack, the CFO decides, the hub runs it.</a:t>
+              <a:t>every case states the headcount and engineering capacity it needs, and Engineering confirms it at the lock, so a release never funds work the platform cannot staff. Partners and GMs own the case and its numbers; I assemble the pack and recommend; the CFO decides; the hub runs the release.</a:t>
             </a:r>
           </a:p>
         </p:txBody>
@@ -26093,7 +26093,7 @@
                 </a:solidFill>
                 <a:latin typeface="Arial"/>
               </a:rPr>
-              <a:t>The Board book goes out 7 days before the meeting, after a lock at 16 days</a:t>
+              <a:t>Every quarter: the book goes out 7 days before the Board, after a lock at 16 days</a:t>
             </a:r>
           </a:p>
         </p:txBody>
@@ -26106,8 +26106,8 @@
         </p:nvSpPr>
         <p:spPr>
           <a:xfrm>
-            <a:off x="612648" y="1481328"/>
-            <a:ext cx="10789920" cy="411480"/>
+            <a:off x="612648" y="1463040"/>
+            <a:ext cx="10789920" cy="566928"/>
           </a:xfrm>
           <a:prstGeom prst="rect">
             <a:avLst/>
@@ -26122,7 +26122,7 @@
           <a:p>
             <a:pPr algn="l"/>
             <a:r>
-              <a:rPr sz="1200" b="1">
+              <a:rPr sz="1150" b="1">
                 <a:solidFill>
                   <a:srgbClr val="11052C"/>
                 </a:solidFill>
@@ -26131,13 +26131,13 @@
               <a:t>Why the book is late: </a:t>
             </a:r>
             <a:r>
-              <a:rPr sz="1200" b="0">
+              <a:rPr sz="1150" b="0">
                 <a:solidFill>
                   <a:srgbClr val="11052C"/>
                 </a:solidFill>
                 <a:latin typeface="Arial"/>
               </a:rPr>
-              <a:t>no locked outline, no standard data tables, and units building rival decks. The fix starts today, with the Corporate Secretary.</a:t>
+              <a:t>no locked outline, no standard data tables, and units building rival decks. The fix starts today, with the Corporate Secretary, and the same countdown then runs for every Board from the Secretary's calendar. That calendar is the one the ask approves.</a:t>
             </a:r>
           </a:p>
         </p:txBody>
@@ -26150,8 +26150,8 @@
         </p:nvSpPr>
         <p:spPr>
           <a:xfrm>
-            <a:off x="612648" y="1938528"/>
-            <a:ext cx="2560320" cy="1783080"/>
+            <a:off x="612648" y="2075688"/>
+            <a:ext cx="2560320" cy="1691640"/>
           </a:xfrm>
           <a:prstGeom prst="roundRect">
             <a:avLst>
@@ -26196,8 +26196,8 @@
         </p:nvSpPr>
         <p:spPr>
           <a:xfrm>
-            <a:off x="722376" y="2048256"/>
-            <a:ext cx="2340863" cy="1600200"/>
+            <a:off x="722376" y="2185416"/>
+            <a:ext cx="2340863" cy="1508760"/>
           </a:xfrm>
           <a:prstGeom prst="rect">
             <a:avLst/>
@@ -26267,8 +26267,8 @@
         </p:nvSpPr>
         <p:spPr>
           <a:xfrm>
-            <a:off x="3355848" y="1938528"/>
-            <a:ext cx="2560320" cy="1783080"/>
+            <a:off x="3355848" y="2075688"/>
+            <a:ext cx="2560320" cy="1691640"/>
           </a:xfrm>
           <a:prstGeom prst="roundRect">
             <a:avLst>
@@ -26313,8 +26313,8 @@
         </p:nvSpPr>
         <p:spPr>
           <a:xfrm>
-            <a:off x="3465576" y="2048256"/>
-            <a:ext cx="2340863" cy="1600200"/>
+            <a:off x="3465576" y="2185416"/>
+            <a:ext cx="2340863" cy="1508760"/>
           </a:xfrm>
           <a:prstGeom prst="rect">
             <a:avLst/>
@@ -26384,8 +26384,8 @@
         </p:nvSpPr>
         <p:spPr>
           <a:xfrm>
-            <a:off x="6099048" y="1938528"/>
-            <a:ext cx="2560320" cy="1783080"/>
+            <a:off x="6099048" y="2075688"/>
+            <a:ext cx="2560320" cy="1691640"/>
           </a:xfrm>
           <a:prstGeom prst="roundRect">
             <a:avLst>
@@ -26430,8 +26430,8 @@
         </p:nvSpPr>
         <p:spPr>
           <a:xfrm>
-            <a:off x="6208776" y="2048256"/>
-            <a:ext cx="2340863" cy="1600200"/>
+            <a:off x="6208776" y="2185416"/>
+            <a:ext cx="2340863" cy="1508760"/>
           </a:xfrm>
           <a:prstGeom prst="rect">
             <a:avLst/>
@@ -26501,8 +26501,8 @@
         </p:nvSpPr>
         <p:spPr>
           <a:xfrm>
-            <a:off x="8842248" y="1938528"/>
-            <a:ext cx="2560320" cy="1783080"/>
+            <a:off x="8842248" y="2075688"/>
+            <a:ext cx="2560320" cy="1691640"/>
           </a:xfrm>
           <a:prstGeom prst="roundRect">
             <a:avLst>
@@ -26547,8 +26547,8 @@
         </p:nvSpPr>
         <p:spPr>
           <a:xfrm>
-            <a:off x="8951976" y="2048256"/>
-            <a:ext cx="2340863" cy="1600200"/>
+            <a:off x="8951976" y="2185416"/>
+            <a:ext cx="2340863" cy="1508760"/>
           </a:xfrm>
           <a:prstGeom prst="rect">
             <a:avLst/>
@@ -26605,7 +26605,7 @@
                 </a:solidFill>
                 <a:latin typeface="Arial"/>
               </a:rPr>
-              <a:t>Directors' data questions are answered in writing by T-3, so the meeting is spent on the capital plan.</a:t>
+              <a:t>Directors' questions are answered in writing by T-3, so the meeting goes to the capital plan.</a:t>
             </a:r>
           </a:p>
         </p:txBody>
@@ -26618,8 +26618,8 @@
         </p:nvSpPr>
         <p:spPr>
           <a:xfrm>
-            <a:off x="612648" y="3840480"/>
-            <a:ext cx="10789920" cy="749808"/>
+            <a:off x="612648" y="3877056"/>
+            <a:ext cx="10789920" cy="731520"/>
           </a:xfrm>
           <a:prstGeom prst="roundRect">
             <a:avLst>
@@ -26664,8 +26664,8 @@
         </p:nvSpPr>
         <p:spPr>
           <a:xfrm>
-            <a:off x="795528" y="3931920"/>
-            <a:ext cx="10424160" cy="603503"/>
+            <a:off x="795528" y="3968496"/>
+            <a:ext cx="10424160" cy="585216"/>
           </a:xfrm>
           <a:prstGeom prst="rect">
             <a:avLst/>

</xml_diff>